<commit_message>
docs: generate public pages for 2026-05-31
</commit_message>
<xml_diff>
--- a/docs/NewsGraspアイコン自作.pptx
+++ b/docs/NewsGraspアイコン自作.pptx
@@ -6,6 +6,9 @@
   </p:sldMasterIdLst>
   <p:sldIdLst>
     <p:sldId id="256" r:id="rId2"/>
+    <p:sldId id="257" r:id="rId3"/>
+    <p:sldId id="259" r:id="rId4"/>
+    <p:sldId id="258" r:id="rId5"/>
   </p:sldIdLst>
   <p:sldSz cx="12192000" cy="6858000"/>
   <p:notesSz cx="6858000" cy="9144000"/>
@@ -280,7 +283,7 @@
           <a:p>
             <a:fld id="{0440BD6B-309C-475F-B0AC-672E322A3E11}" type="datetimeFigureOut">
               <a:rPr kumimoji="1" lang="ja-JP" altLang="en-US" smtClean="0"/>
-              <a:t>2026/5/29</a:t>
+              <a:t>2026/5/30</a:t>
             </a:fld>
             <a:endParaRPr kumimoji="1" lang="ja-JP" altLang="en-US"/>
           </a:p>
@@ -510,7 +513,7 @@
           <a:p>
             <a:fld id="{0440BD6B-309C-475F-B0AC-672E322A3E11}" type="datetimeFigureOut">
               <a:rPr kumimoji="1" lang="ja-JP" altLang="en-US" smtClean="0"/>
-              <a:t>2026/5/29</a:t>
+              <a:t>2026/5/30</a:t>
             </a:fld>
             <a:endParaRPr kumimoji="1" lang="ja-JP" altLang="en-US"/>
           </a:p>
@@ -750,7 +753,7 @@
           <a:p>
             <a:fld id="{0440BD6B-309C-475F-B0AC-672E322A3E11}" type="datetimeFigureOut">
               <a:rPr kumimoji="1" lang="ja-JP" altLang="en-US" smtClean="0"/>
-              <a:t>2026/5/29</a:t>
+              <a:t>2026/5/30</a:t>
             </a:fld>
             <a:endParaRPr kumimoji="1" lang="ja-JP" altLang="en-US"/>
           </a:p>
@@ -980,7 +983,7 @@
           <a:p>
             <a:fld id="{0440BD6B-309C-475F-B0AC-672E322A3E11}" type="datetimeFigureOut">
               <a:rPr kumimoji="1" lang="ja-JP" altLang="en-US" smtClean="0"/>
-              <a:t>2026/5/29</a:t>
+              <a:t>2026/5/30</a:t>
             </a:fld>
             <a:endParaRPr kumimoji="1" lang="ja-JP" altLang="en-US"/>
           </a:p>
@@ -1255,7 +1258,7 @@
           <a:p>
             <a:fld id="{0440BD6B-309C-475F-B0AC-672E322A3E11}" type="datetimeFigureOut">
               <a:rPr kumimoji="1" lang="ja-JP" altLang="en-US" smtClean="0"/>
-              <a:t>2026/5/29</a:t>
+              <a:t>2026/5/30</a:t>
             </a:fld>
             <a:endParaRPr kumimoji="1" lang="ja-JP" altLang="en-US"/>
           </a:p>
@@ -1584,7 +1587,7 @@
           <a:p>
             <a:fld id="{0440BD6B-309C-475F-B0AC-672E322A3E11}" type="datetimeFigureOut">
               <a:rPr kumimoji="1" lang="ja-JP" altLang="en-US" smtClean="0"/>
-              <a:t>2026/5/29</a:t>
+              <a:t>2026/5/30</a:t>
             </a:fld>
             <a:endParaRPr kumimoji="1" lang="ja-JP" altLang="en-US"/>
           </a:p>
@@ -2060,7 +2063,7 @@
           <a:p>
             <a:fld id="{0440BD6B-309C-475F-B0AC-672E322A3E11}" type="datetimeFigureOut">
               <a:rPr kumimoji="1" lang="ja-JP" altLang="en-US" smtClean="0"/>
-              <a:t>2026/5/29</a:t>
+              <a:t>2026/5/30</a:t>
             </a:fld>
             <a:endParaRPr kumimoji="1" lang="ja-JP" altLang="en-US"/>
           </a:p>
@@ -2201,7 +2204,7 @@
           <a:p>
             <a:fld id="{0440BD6B-309C-475F-B0AC-672E322A3E11}" type="datetimeFigureOut">
               <a:rPr kumimoji="1" lang="ja-JP" altLang="en-US" smtClean="0"/>
-              <a:t>2026/5/29</a:t>
+              <a:t>2026/5/30</a:t>
             </a:fld>
             <a:endParaRPr kumimoji="1" lang="ja-JP" altLang="en-US"/>
           </a:p>
@@ -2314,7 +2317,7 @@
           <a:p>
             <a:fld id="{0440BD6B-309C-475F-B0AC-672E322A3E11}" type="datetimeFigureOut">
               <a:rPr kumimoji="1" lang="ja-JP" altLang="en-US" smtClean="0"/>
-              <a:t>2026/5/29</a:t>
+              <a:t>2026/5/30</a:t>
             </a:fld>
             <a:endParaRPr kumimoji="1" lang="ja-JP" altLang="en-US"/>
           </a:p>
@@ -2657,7 +2660,7 @@
           <a:p>
             <a:fld id="{0440BD6B-309C-475F-B0AC-672E322A3E11}" type="datetimeFigureOut">
               <a:rPr kumimoji="1" lang="ja-JP" altLang="en-US" smtClean="0"/>
-              <a:t>2026/5/29</a:t>
+              <a:t>2026/5/30</a:t>
             </a:fld>
             <a:endParaRPr kumimoji="1" lang="ja-JP" altLang="en-US"/>
           </a:p>
@@ -2945,7 +2948,7 @@
           <a:p>
             <a:fld id="{0440BD6B-309C-475F-B0AC-672E322A3E11}" type="datetimeFigureOut">
               <a:rPr kumimoji="1" lang="ja-JP" altLang="en-US" smtClean="0"/>
-              <a:t>2026/5/29</a:t>
+              <a:t>2026/5/30</a:t>
             </a:fld>
             <a:endParaRPr kumimoji="1" lang="ja-JP" altLang="en-US"/>
           </a:p>
@@ -3218,7 +3221,7 @@
           <a:p>
             <a:fld id="{0440BD6B-309C-475F-B0AC-672E322A3E11}" type="datetimeFigureOut">
               <a:rPr kumimoji="1" lang="ja-JP" altLang="en-US" smtClean="0"/>
-              <a:t>2026/5/29</a:t>
+              <a:t>2026/5/30</a:t>
             </a:fld>
             <a:endParaRPr kumimoji="1" lang="ja-JP" altLang="en-US"/>
           </a:p>
@@ -5103,15 +5106,15 @@
         </p:nvPicPr>
         <p:blipFill>
           <a:blip r:embed="rId12"/>
-          <a:srcRect t="41026" r="74832"/>
+          <a:srcRect t="33703" r="74832"/>
           <a:stretch>
             <a:fillRect/>
           </a:stretch>
         </p:blipFill>
         <p:spPr>
           <a:xfrm>
-            <a:off x="1137541" y="3394529"/>
-            <a:ext cx="857792" cy="1797202"/>
+            <a:off x="1141170" y="3171371"/>
+            <a:ext cx="857792" cy="2020360"/>
           </a:xfrm>
           <a:prstGeom prst="rect">
             <a:avLst/>
@@ -5153,6 +5156,442 @@
     <p:extLst>
       <p:ext uri="{BB962C8B-B14F-4D97-AF65-F5344CB8AC3E}">
         <p14:creationId xmlns:p14="http://schemas.microsoft.com/office/powerpoint/2010/main" val="532685052"/>
+      </p:ext>
+    </p:extLst>
+  </p:cSld>
+  <p:clrMapOvr>
+    <a:masterClrMapping/>
+  </p:clrMapOvr>
+</p:sld>
+</file>
+
+<file path=ppt/slides/slide2.xml><?xml version="1.0" encoding="utf-8"?>
+<p:sld xmlns:a="http://schemas.openxmlformats.org/drawingml/2006/main" xmlns:r="http://schemas.openxmlformats.org/officeDocument/2006/relationships" xmlns:p="http://schemas.openxmlformats.org/presentationml/2006/main">
+  <p:cSld>
+    <p:spTree>
+      <p:nvGrpSpPr>
+        <p:cNvPr id="1" name=""/>
+        <p:cNvGrpSpPr/>
+        <p:nvPr/>
+      </p:nvGrpSpPr>
+      <p:grpSpPr>
+        <a:xfrm>
+          <a:off x="0" y="0"/>
+          <a:ext cx="0" cy="0"/>
+          <a:chOff x="0" y="0"/>
+          <a:chExt cx="0" cy="0"/>
+        </a:xfrm>
+      </p:grpSpPr>
+      <p:pic>
+        <p:nvPicPr>
+          <p:cNvPr id="5" name="図 4">
+            <a:extLst>
+              <a:ext uri="{FF2B5EF4-FFF2-40B4-BE49-F238E27FC236}">
+                <a16:creationId xmlns:a16="http://schemas.microsoft.com/office/drawing/2014/main" id="{87A41AC0-5887-5DF2-B3E2-00BAFEED98AD}"/>
+              </a:ext>
+            </a:extLst>
+          </p:cNvPr>
+          <p:cNvPicPr>
+            <a:picLocks noChangeAspect="1"/>
+          </p:cNvPicPr>
+          <p:nvPr/>
+        </p:nvPicPr>
+        <p:blipFill>
+          <a:blip r:embed="rId2"/>
+          <a:stretch>
+            <a:fillRect/>
+          </a:stretch>
+        </p:blipFill>
+        <p:spPr>
+          <a:xfrm>
+            <a:off x="596430" y="0"/>
+            <a:ext cx="10999140" cy="6858000"/>
+          </a:xfrm>
+          <a:prstGeom prst="rect">
+            <a:avLst/>
+          </a:prstGeom>
+        </p:spPr>
+      </p:pic>
+      <p:pic>
+        <p:nvPicPr>
+          <p:cNvPr id="6" name="図 5">
+            <a:extLst>
+              <a:ext uri="{FF2B5EF4-FFF2-40B4-BE49-F238E27FC236}">
+                <a16:creationId xmlns:a16="http://schemas.microsoft.com/office/drawing/2014/main" id="{43440235-4358-DC08-CE56-10411BCE0B38}"/>
+              </a:ext>
+            </a:extLst>
+          </p:cNvPr>
+          <p:cNvPicPr>
+            <a:picLocks noChangeAspect="1"/>
+          </p:cNvPicPr>
+          <p:nvPr/>
+        </p:nvPicPr>
+        <p:blipFill>
+          <a:blip r:embed="rId3">
+            <a:clrChange>
+              <a:clrFrom>
+                <a:srgbClr val="15192A"/>
+              </a:clrFrom>
+              <a:clrTo>
+                <a:srgbClr val="15192A">
+                  <a:alpha val="0"/>
+                </a:srgbClr>
+              </a:clrTo>
+            </a:clrChange>
+          </a:blip>
+          <a:stretch>
+            <a:fillRect/>
+          </a:stretch>
+        </p:blipFill>
+        <p:spPr>
+          <a:xfrm>
+            <a:off x="1174609" y="281390"/>
+            <a:ext cx="5190842" cy="1006045"/>
+          </a:xfrm>
+          <a:prstGeom prst="rect">
+            <a:avLst/>
+          </a:prstGeom>
+        </p:spPr>
+      </p:pic>
+    </p:spTree>
+    <p:extLst>
+      <p:ext uri="{BB962C8B-B14F-4D97-AF65-F5344CB8AC3E}">
+        <p14:creationId xmlns:p14="http://schemas.microsoft.com/office/powerpoint/2010/main" val="1463063242"/>
+      </p:ext>
+    </p:extLst>
+  </p:cSld>
+  <p:clrMapOvr>
+    <a:masterClrMapping/>
+  </p:clrMapOvr>
+</p:sld>
+</file>
+
+<file path=ppt/slides/slide3.xml><?xml version="1.0" encoding="utf-8"?>
+<p:sld xmlns:a="http://schemas.openxmlformats.org/drawingml/2006/main" xmlns:r="http://schemas.openxmlformats.org/officeDocument/2006/relationships" xmlns:p="http://schemas.openxmlformats.org/presentationml/2006/main">
+  <p:cSld>
+    <p:spTree>
+      <p:nvGrpSpPr>
+        <p:cNvPr id="1" name=""/>
+        <p:cNvGrpSpPr/>
+        <p:nvPr/>
+      </p:nvGrpSpPr>
+      <p:grpSpPr>
+        <a:xfrm>
+          <a:off x="0" y="0"/>
+          <a:ext cx="0" cy="0"/>
+          <a:chOff x="0" y="0"/>
+          <a:chExt cx="0" cy="0"/>
+        </a:xfrm>
+      </p:grpSpPr>
+      <p:pic>
+        <p:nvPicPr>
+          <p:cNvPr id="5" name="図 4">
+            <a:extLst>
+              <a:ext uri="{FF2B5EF4-FFF2-40B4-BE49-F238E27FC236}">
+                <a16:creationId xmlns:a16="http://schemas.microsoft.com/office/drawing/2014/main" id="{AEFF5F98-37AD-0E03-B4CD-9CE948929E10}"/>
+              </a:ext>
+            </a:extLst>
+          </p:cNvPr>
+          <p:cNvPicPr>
+            <a:picLocks noChangeAspect="1"/>
+          </p:cNvPicPr>
+          <p:nvPr/>
+        </p:nvPicPr>
+        <p:blipFill>
+          <a:blip r:embed="rId2"/>
+          <a:stretch>
+            <a:fillRect/>
+          </a:stretch>
+        </p:blipFill>
+        <p:spPr>
+          <a:xfrm>
+            <a:off x="0" y="292066"/>
+            <a:ext cx="12192000" cy="6273867"/>
+          </a:xfrm>
+          <a:prstGeom prst="rect">
+            <a:avLst/>
+          </a:prstGeom>
+        </p:spPr>
+      </p:pic>
+      <p:pic>
+        <p:nvPicPr>
+          <p:cNvPr id="6" name="図 5">
+            <a:extLst>
+              <a:ext uri="{FF2B5EF4-FFF2-40B4-BE49-F238E27FC236}">
+                <a16:creationId xmlns:a16="http://schemas.microsoft.com/office/drawing/2014/main" id="{91D256B8-2E62-10E4-E658-1A4BCBDABE29}"/>
+              </a:ext>
+            </a:extLst>
+          </p:cNvPr>
+          <p:cNvPicPr>
+            <a:picLocks noChangeAspect="1"/>
+          </p:cNvPicPr>
+          <p:nvPr/>
+        </p:nvPicPr>
+        <p:blipFill>
+          <a:blip r:embed="rId3">
+            <a:clrChange>
+              <a:clrFrom>
+                <a:srgbClr val="15192A"/>
+              </a:clrFrom>
+              <a:clrTo>
+                <a:srgbClr val="15192A">
+                  <a:alpha val="0"/>
+                </a:srgbClr>
+              </a:clrTo>
+            </a:clrChange>
+          </a:blip>
+          <a:stretch>
+            <a:fillRect/>
+          </a:stretch>
+        </p:blipFill>
+        <p:spPr>
+          <a:xfrm>
+            <a:off x="351936" y="576782"/>
+            <a:ext cx="2387560" cy="462737"/>
+          </a:xfrm>
+          <a:prstGeom prst="rect">
+            <a:avLst/>
+          </a:prstGeom>
+        </p:spPr>
+      </p:pic>
+    </p:spTree>
+    <p:extLst>
+      <p:ext uri="{BB962C8B-B14F-4D97-AF65-F5344CB8AC3E}">
+        <p14:creationId xmlns:p14="http://schemas.microsoft.com/office/powerpoint/2010/main" val="2618487468"/>
+      </p:ext>
+    </p:extLst>
+  </p:cSld>
+  <p:clrMapOvr>
+    <a:masterClrMapping/>
+  </p:clrMapOvr>
+</p:sld>
+</file>
+
+<file path=ppt/slides/slide4.xml><?xml version="1.0" encoding="utf-8"?>
+<p:sld xmlns:a="http://schemas.openxmlformats.org/drawingml/2006/main" xmlns:r="http://schemas.openxmlformats.org/officeDocument/2006/relationships" xmlns:p="http://schemas.openxmlformats.org/presentationml/2006/main">
+  <p:cSld>
+    <p:spTree>
+      <p:nvGrpSpPr>
+        <p:cNvPr id="1" name=""/>
+        <p:cNvGrpSpPr/>
+        <p:nvPr/>
+      </p:nvGrpSpPr>
+      <p:grpSpPr>
+        <a:xfrm>
+          <a:off x="0" y="0"/>
+          <a:ext cx="0" cy="0"/>
+          <a:chOff x="0" y="0"/>
+          <a:chExt cx="0" cy="0"/>
+        </a:xfrm>
+      </p:grpSpPr>
+      <p:sp>
+        <p:nvSpPr>
+          <p:cNvPr id="4" name="AutoShape 2">
+            <a:extLst>
+              <a:ext uri="{FF2B5EF4-FFF2-40B4-BE49-F238E27FC236}">
+                <a16:creationId xmlns:a16="http://schemas.microsoft.com/office/drawing/2014/main" id="{E3FEFD16-D57B-46AD-1A8D-56692D24D83E}"/>
+              </a:ext>
+            </a:extLst>
+          </p:cNvPr>
+          <p:cNvSpPr>
+            <a:spLocks noChangeAspect="1" noChangeArrowheads="1"/>
+          </p:cNvSpPr>
+          <p:nvPr/>
+        </p:nvSpPr>
+        <p:spPr bwMode="auto">
+          <a:xfrm>
+            <a:off x="5943600" y="3276600"/>
+            <a:ext cx="304800" cy="304800"/>
+          </a:xfrm>
+          <a:prstGeom prst="rect">
+            <a:avLst/>
+          </a:prstGeom>
+          <a:noFill/>
+          <a:extLst>
+            <a:ext uri="{909E8E84-426E-40DD-AFC4-6F175D3DCCD1}">
+              <a14:hiddenFill xmlns:a14="http://schemas.microsoft.com/office/drawing/2010/main">
+                <a:solidFill>
+                  <a:srgbClr val="FFFFFF"/>
+                </a:solidFill>
+              </a14:hiddenFill>
+            </a:ext>
+          </a:extLst>
+        </p:spPr>
+        <p:txBody>
+          <a:bodyPr vert="horz" wrap="square" lIns="91440" tIns="45720" rIns="91440" bIns="45720" numCol="1" anchor="t" anchorCtr="0" compatLnSpc="1">
+            <a:prstTxWarp prst="textNoShape">
+              <a:avLst/>
+            </a:prstTxWarp>
+          </a:bodyPr>
+          <a:lstStyle/>
+          <a:p>
+            <a:endParaRPr lang="ja-JP" altLang="en-US"/>
+          </a:p>
+        </p:txBody>
+      </p:sp>
+      <p:pic>
+        <p:nvPicPr>
+          <p:cNvPr id="6" name="図 5">
+            <a:extLst>
+              <a:ext uri="{FF2B5EF4-FFF2-40B4-BE49-F238E27FC236}">
+                <a16:creationId xmlns:a16="http://schemas.microsoft.com/office/drawing/2014/main" id="{BFBBC957-49F7-483F-A626-24378A216897}"/>
+              </a:ext>
+            </a:extLst>
+          </p:cNvPr>
+          <p:cNvPicPr>
+            <a:picLocks noChangeAspect="1"/>
+          </p:cNvPicPr>
+          <p:nvPr/>
+        </p:nvPicPr>
+        <p:blipFill>
+          <a:blip r:embed="rId2">
+            <a:extLst>
+              <a:ext uri="{28A0092B-C50C-407E-A947-70E740481C1C}">
+                <a14:useLocalDpi xmlns:a14="http://schemas.microsoft.com/office/drawing/2010/main" val="0"/>
+              </a:ext>
+            </a:extLst>
+          </a:blip>
+          <a:stretch>
+            <a:fillRect/>
+          </a:stretch>
+        </p:blipFill>
+        <p:spPr>
+          <a:xfrm>
+            <a:off x="4536050" y="0"/>
+            <a:ext cx="3119899" cy="6858000"/>
+          </a:xfrm>
+          <a:prstGeom prst="rect">
+            <a:avLst/>
+          </a:prstGeom>
+        </p:spPr>
+      </p:pic>
+      <p:pic>
+        <p:nvPicPr>
+          <p:cNvPr id="8" name="図 7">
+            <a:extLst>
+              <a:ext uri="{FF2B5EF4-FFF2-40B4-BE49-F238E27FC236}">
+                <a16:creationId xmlns:a16="http://schemas.microsoft.com/office/drawing/2014/main" id="{59B6D73D-402E-B35F-9511-807D486235EE}"/>
+              </a:ext>
+            </a:extLst>
+          </p:cNvPr>
+          <p:cNvPicPr>
+            <a:picLocks noChangeAspect="1"/>
+          </p:cNvPicPr>
+          <p:nvPr/>
+        </p:nvPicPr>
+        <p:blipFill>
+          <a:blip r:embed="rId3">
+            <a:extLst>
+              <a:ext uri="{28A0092B-C50C-407E-A947-70E740481C1C}">
+                <a14:useLocalDpi xmlns:a14="http://schemas.microsoft.com/office/drawing/2010/main" val="0"/>
+              </a:ext>
+            </a:extLst>
+          </a:blip>
+          <a:stretch>
+            <a:fillRect/>
+          </a:stretch>
+        </p:blipFill>
+        <p:spPr>
+          <a:xfrm>
+            <a:off x="1111206" y="0"/>
+            <a:ext cx="3119899" cy="6858000"/>
+          </a:xfrm>
+          <a:prstGeom prst="rect">
+            <a:avLst/>
+          </a:prstGeom>
+        </p:spPr>
+      </p:pic>
+      <p:pic>
+        <p:nvPicPr>
+          <p:cNvPr id="10" name="図 9">
+            <a:extLst>
+              <a:ext uri="{FF2B5EF4-FFF2-40B4-BE49-F238E27FC236}">
+                <a16:creationId xmlns:a16="http://schemas.microsoft.com/office/drawing/2014/main" id="{09283618-C276-F6D0-B6E7-EB99527B2667}"/>
+              </a:ext>
+            </a:extLst>
+          </p:cNvPr>
+          <p:cNvPicPr>
+            <a:picLocks noChangeAspect="1"/>
+          </p:cNvPicPr>
+          <p:nvPr/>
+        </p:nvPicPr>
+        <p:blipFill>
+          <a:blip r:embed="rId4">
+            <a:clrChange>
+              <a:clrFrom>
+                <a:srgbClr val="000000"/>
+              </a:clrFrom>
+              <a:clrTo>
+                <a:srgbClr val="000000">
+                  <a:alpha val="0"/>
+                </a:srgbClr>
+              </a:clrTo>
+            </a:clrChange>
+            <a:extLst>
+              <a:ext uri="{28A0092B-C50C-407E-A947-70E740481C1C}">
+                <a14:useLocalDpi xmlns:a14="http://schemas.microsoft.com/office/drawing/2010/main" val="0"/>
+              </a:ext>
+            </a:extLst>
+          </a:blip>
+          <a:stretch>
+            <a:fillRect/>
+          </a:stretch>
+        </p:blipFill>
+        <p:spPr>
+          <a:xfrm>
+            <a:off x="3465799" y="662390"/>
+            <a:ext cx="456591" cy="460841"/>
+          </a:xfrm>
+          <a:prstGeom prst="rect">
+            <a:avLst/>
+          </a:prstGeom>
+        </p:spPr>
+      </p:pic>
+      <p:pic>
+        <p:nvPicPr>
+          <p:cNvPr id="13" name="図 12">
+            <a:extLst>
+              <a:ext uri="{FF2B5EF4-FFF2-40B4-BE49-F238E27FC236}">
+                <a16:creationId xmlns:a16="http://schemas.microsoft.com/office/drawing/2014/main" id="{320C5AD3-58AB-A828-366A-34F73323ABBA}"/>
+              </a:ext>
+            </a:extLst>
+          </p:cNvPr>
+          <p:cNvPicPr>
+            <a:picLocks noChangeAspect="1"/>
+          </p:cNvPicPr>
+          <p:nvPr/>
+        </p:nvPicPr>
+        <p:blipFill>
+          <a:blip r:embed="rId5">
+            <a:clrChange>
+              <a:clrFrom>
+                <a:srgbClr val="15192A"/>
+              </a:clrFrom>
+              <a:clrTo>
+                <a:srgbClr val="15192A">
+                  <a:alpha val="0"/>
+                </a:srgbClr>
+              </a:clrTo>
+            </a:clrChange>
+          </a:blip>
+          <a:stretch>
+            <a:fillRect/>
+          </a:stretch>
+        </p:blipFill>
+        <p:spPr>
+          <a:xfrm>
+            <a:off x="4661232" y="586696"/>
+            <a:ext cx="1394385" cy="270248"/>
+          </a:xfrm>
+          <a:prstGeom prst="rect">
+            <a:avLst/>
+          </a:prstGeom>
+        </p:spPr>
+      </p:pic>
+    </p:spTree>
+    <p:extLst>
+      <p:ext uri="{BB962C8B-B14F-4D97-AF65-F5344CB8AC3E}">
+        <p14:creationId xmlns:p14="http://schemas.microsoft.com/office/powerpoint/2010/main" val="1929965221"/>
       </p:ext>
     </p:extLst>
   </p:cSld>

</xml_diff>

<commit_message>
docs: generate public pages for 2026-06-05
</commit_message>
<xml_diff>
--- a/docs/NewsGraspアイコン自作.pptx
+++ b/docs/NewsGraspアイコン自作.pptx
@@ -9,6 +9,13 @@
     <p:sldId id="257" r:id="rId3"/>
     <p:sldId id="259" r:id="rId4"/>
     <p:sldId id="258" r:id="rId5"/>
+    <p:sldId id="260" r:id="rId6"/>
+    <p:sldId id="261" r:id="rId7"/>
+    <p:sldId id="262" r:id="rId8"/>
+    <p:sldId id="263" r:id="rId9"/>
+    <p:sldId id="264" r:id="rId10"/>
+    <p:sldId id="265" r:id="rId11"/>
+    <p:sldId id="266" r:id="rId12"/>
   </p:sldIdLst>
   <p:sldSz cx="12192000" cy="6858000"/>
   <p:notesSz cx="6858000" cy="9144000"/>
@@ -5165,6 +5172,561 @@
 </p:sld>
 </file>
 
+<file path=ppt/slides/slide10.xml><?xml version="1.0" encoding="utf-8"?>
+<p:sld xmlns:a="http://schemas.openxmlformats.org/drawingml/2006/main" xmlns:r="http://schemas.openxmlformats.org/officeDocument/2006/relationships" xmlns:p="http://schemas.openxmlformats.org/presentationml/2006/main">
+  <p:cSld>
+    <p:spTree>
+      <p:nvGrpSpPr>
+        <p:cNvPr id="1" name="">
+          <a:extLst>
+            <a:ext uri="{FF2B5EF4-FFF2-40B4-BE49-F238E27FC236}">
+              <a16:creationId xmlns:a16="http://schemas.microsoft.com/office/drawing/2014/main" id="{49F243D7-5160-C734-E559-C3429AEF0F54}"/>
+            </a:ext>
+          </a:extLst>
+        </p:cNvPr>
+        <p:cNvGrpSpPr/>
+        <p:nvPr/>
+      </p:nvGrpSpPr>
+      <p:grpSpPr>
+        <a:xfrm>
+          <a:off x="0" y="0"/>
+          <a:ext cx="0" cy="0"/>
+          <a:chOff x="0" y="0"/>
+          <a:chExt cx="0" cy="0"/>
+        </a:xfrm>
+      </p:grpSpPr>
+      <p:pic>
+        <p:nvPicPr>
+          <p:cNvPr id="5" name="図 4">
+            <a:extLst>
+              <a:ext uri="{FF2B5EF4-FFF2-40B4-BE49-F238E27FC236}">
+                <a16:creationId xmlns:a16="http://schemas.microsoft.com/office/drawing/2014/main" id="{F0483CE6-282E-0A5E-DD86-3253C2ED59A8}"/>
+              </a:ext>
+            </a:extLst>
+          </p:cNvPr>
+          <p:cNvPicPr>
+            <a:picLocks noChangeAspect="1"/>
+          </p:cNvPicPr>
+          <p:nvPr/>
+        </p:nvPicPr>
+        <p:blipFill>
+          <a:blip r:embed="rId2"/>
+          <a:stretch>
+            <a:fillRect/>
+          </a:stretch>
+        </p:blipFill>
+        <p:spPr>
+          <a:xfrm>
+            <a:off x="0" y="471401"/>
+            <a:ext cx="12192000" cy="5915198"/>
+          </a:xfrm>
+          <a:prstGeom prst="rect">
+            <a:avLst/>
+          </a:prstGeom>
+        </p:spPr>
+      </p:pic>
+      <p:pic>
+        <p:nvPicPr>
+          <p:cNvPr id="2" name="図 1">
+            <a:extLst>
+              <a:ext uri="{FF2B5EF4-FFF2-40B4-BE49-F238E27FC236}">
+                <a16:creationId xmlns:a16="http://schemas.microsoft.com/office/drawing/2014/main" id="{CAC75AB7-70D8-13E0-7030-7852DD33C519}"/>
+              </a:ext>
+            </a:extLst>
+          </p:cNvPr>
+          <p:cNvPicPr>
+            <a:picLocks noChangeAspect="1"/>
+          </p:cNvPicPr>
+          <p:nvPr/>
+        </p:nvPicPr>
+        <p:blipFill>
+          <a:blip r:embed="rId2"/>
+          <a:srcRect l="2024" t="58036" r="82679" b="3196"/>
+          <a:stretch>
+            <a:fillRect/>
+          </a:stretch>
+        </p:blipFill>
+        <p:spPr>
+          <a:xfrm>
+            <a:off x="8135256" y="3839028"/>
+            <a:ext cx="1865085" cy="2293257"/>
+          </a:xfrm>
+          <a:prstGeom prst="rect">
+            <a:avLst/>
+          </a:prstGeom>
+        </p:spPr>
+      </p:pic>
+      <p:pic>
+        <p:nvPicPr>
+          <p:cNvPr id="3" name="図 2">
+            <a:extLst>
+              <a:ext uri="{FF2B5EF4-FFF2-40B4-BE49-F238E27FC236}">
+                <a16:creationId xmlns:a16="http://schemas.microsoft.com/office/drawing/2014/main" id="{5B416467-BBE8-BF95-00C7-C19D3B4CD309}"/>
+              </a:ext>
+            </a:extLst>
+          </p:cNvPr>
+          <p:cNvPicPr>
+            <a:picLocks noChangeAspect="1"/>
+          </p:cNvPicPr>
+          <p:nvPr/>
+        </p:nvPicPr>
+        <p:blipFill>
+          <a:blip r:embed="rId2"/>
+          <a:srcRect l="82500" t="58036" r="1131"/>
+          <a:stretch>
+            <a:fillRect/>
+          </a:stretch>
+        </p:blipFill>
+        <p:spPr>
+          <a:xfrm>
+            <a:off x="152400" y="3839028"/>
+            <a:ext cx="1995714" cy="2482256"/>
+          </a:xfrm>
+          <a:prstGeom prst="rect">
+            <a:avLst/>
+          </a:prstGeom>
+        </p:spPr>
+      </p:pic>
+      <p:pic>
+        <p:nvPicPr>
+          <p:cNvPr id="4" name="図 3">
+            <a:extLst>
+              <a:ext uri="{FF2B5EF4-FFF2-40B4-BE49-F238E27FC236}">
+                <a16:creationId xmlns:a16="http://schemas.microsoft.com/office/drawing/2014/main" id="{BD860E09-DCA9-8583-7F89-3E2F1FEC362F}"/>
+              </a:ext>
+            </a:extLst>
+          </p:cNvPr>
+          <p:cNvPicPr>
+            <a:picLocks noChangeAspect="1"/>
+          </p:cNvPicPr>
+          <p:nvPr/>
+        </p:nvPicPr>
+        <p:blipFill>
+          <a:blip r:embed="rId2"/>
+          <a:srcRect l="82500" t="58036" r="1131"/>
+          <a:stretch>
+            <a:fillRect/>
+          </a:stretch>
+        </p:blipFill>
+        <p:spPr>
+          <a:xfrm>
+            <a:off x="10043886" y="1480457"/>
+            <a:ext cx="1995714" cy="2482256"/>
+          </a:xfrm>
+          <a:prstGeom prst="rect">
+            <a:avLst/>
+          </a:prstGeom>
+        </p:spPr>
+      </p:pic>
+      <p:pic>
+        <p:nvPicPr>
+          <p:cNvPr id="6" name="図 5">
+            <a:extLst>
+              <a:ext uri="{FF2B5EF4-FFF2-40B4-BE49-F238E27FC236}">
+                <a16:creationId xmlns:a16="http://schemas.microsoft.com/office/drawing/2014/main" id="{E68D88CF-AB56-60C1-570F-51B931FF485C}"/>
+              </a:ext>
+            </a:extLst>
+          </p:cNvPr>
+          <p:cNvPicPr>
+            <a:picLocks noChangeAspect="1"/>
+          </p:cNvPicPr>
+          <p:nvPr/>
+        </p:nvPicPr>
+        <p:blipFill>
+          <a:blip r:embed="rId2"/>
+          <a:srcRect l="82738" t="17193" r="1964" b="44038"/>
+          <a:stretch>
+            <a:fillRect/>
+          </a:stretch>
+        </p:blipFill>
+        <p:spPr>
+          <a:xfrm>
+            <a:off x="261257" y="3926429"/>
+            <a:ext cx="1865085" cy="2293257"/>
+          </a:xfrm>
+          <a:prstGeom prst="rect">
+            <a:avLst/>
+          </a:prstGeom>
+        </p:spPr>
+      </p:pic>
+      <p:pic>
+        <p:nvPicPr>
+          <p:cNvPr id="8" name="図 7">
+            <a:extLst>
+              <a:ext uri="{FF2B5EF4-FFF2-40B4-BE49-F238E27FC236}">
+                <a16:creationId xmlns:a16="http://schemas.microsoft.com/office/drawing/2014/main" id="{6BE404DE-9B45-1CBF-CC23-8D54F1E97BC7}"/>
+              </a:ext>
+            </a:extLst>
+          </p:cNvPr>
+          <p:cNvPicPr>
+            <a:picLocks noChangeAspect="1"/>
+          </p:cNvPicPr>
+          <p:nvPr/>
+        </p:nvPicPr>
+        <p:blipFill>
+          <a:blip r:embed="rId2"/>
+          <a:srcRect l="82500" t="58036" r="1131"/>
+          <a:stretch>
+            <a:fillRect/>
+          </a:stretch>
+        </p:blipFill>
+        <p:spPr>
+          <a:xfrm>
+            <a:off x="4187372" y="1480457"/>
+            <a:ext cx="1995714" cy="2482256"/>
+          </a:xfrm>
+          <a:prstGeom prst="rect">
+            <a:avLst/>
+          </a:prstGeom>
+        </p:spPr>
+      </p:pic>
+      <p:pic>
+        <p:nvPicPr>
+          <p:cNvPr id="7" name="図 6">
+            <a:extLst>
+              <a:ext uri="{FF2B5EF4-FFF2-40B4-BE49-F238E27FC236}">
+                <a16:creationId xmlns:a16="http://schemas.microsoft.com/office/drawing/2014/main" id="{0508E3C1-E791-A1EA-9399-04469F527C26}"/>
+              </a:ext>
+            </a:extLst>
+          </p:cNvPr>
+          <p:cNvPicPr>
+            <a:picLocks noChangeAspect="1"/>
+          </p:cNvPicPr>
+          <p:nvPr/>
+        </p:nvPicPr>
+        <p:blipFill>
+          <a:blip r:embed="rId2"/>
+          <a:srcRect l="34227" t="17238" r="50535" b="43871"/>
+          <a:stretch>
+            <a:fillRect/>
+          </a:stretch>
+        </p:blipFill>
+        <p:spPr>
+          <a:xfrm>
+            <a:off x="6139542" y="3824512"/>
+            <a:ext cx="1857830" cy="2300515"/>
+          </a:xfrm>
+          <a:prstGeom prst="rect">
+            <a:avLst/>
+          </a:prstGeom>
+        </p:spPr>
+      </p:pic>
+    </p:spTree>
+    <p:extLst>
+      <p:ext uri="{BB962C8B-B14F-4D97-AF65-F5344CB8AC3E}">
+        <p14:creationId xmlns:p14="http://schemas.microsoft.com/office/powerpoint/2010/main" val="919783315"/>
+      </p:ext>
+    </p:extLst>
+  </p:cSld>
+  <p:clrMapOvr>
+    <a:masterClrMapping/>
+  </p:clrMapOvr>
+</p:sld>
+</file>
+
+<file path=ppt/slides/slide11.xml><?xml version="1.0" encoding="utf-8"?>
+<p:sld xmlns:a="http://schemas.openxmlformats.org/drawingml/2006/main" xmlns:r="http://schemas.openxmlformats.org/officeDocument/2006/relationships" xmlns:p="http://schemas.openxmlformats.org/presentationml/2006/main">
+  <p:cSld>
+    <p:spTree>
+      <p:nvGrpSpPr>
+        <p:cNvPr id="1" name=""/>
+        <p:cNvGrpSpPr/>
+        <p:nvPr/>
+      </p:nvGrpSpPr>
+      <p:grpSpPr>
+        <a:xfrm>
+          <a:off x="0" y="0"/>
+          <a:ext cx="0" cy="0"/>
+          <a:chOff x="0" y="0"/>
+          <a:chExt cx="0" cy="0"/>
+        </a:xfrm>
+      </p:grpSpPr>
+      <p:pic>
+        <p:nvPicPr>
+          <p:cNvPr id="13" name="図 12">
+            <a:extLst>
+              <a:ext uri="{FF2B5EF4-FFF2-40B4-BE49-F238E27FC236}">
+                <a16:creationId xmlns:a16="http://schemas.microsoft.com/office/drawing/2014/main" id="{C56851BE-71E4-20EA-0214-BA6C4540C91C}"/>
+              </a:ext>
+            </a:extLst>
+          </p:cNvPr>
+          <p:cNvPicPr>
+            <a:picLocks noChangeAspect="1"/>
+          </p:cNvPicPr>
+          <p:nvPr/>
+        </p:nvPicPr>
+        <p:blipFill>
+          <a:blip r:embed="rId2"/>
+          <a:srcRect l="1141" t="31836" r="89659"/>
+          <a:stretch>
+            <a:fillRect/>
+          </a:stretch>
+        </p:blipFill>
+        <p:spPr>
+          <a:xfrm>
+            <a:off x="7092541" y="1690688"/>
+            <a:ext cx="4664177" cy="5789132"/>
+          </a:xfrm>
+          <a:prstGeom prst="rect">
+            <a:avLst/>
+          </a:prstGeom>
+        </p:spPr>
+      </p:pic>
+      <p:sp>
+        <p:nvSpPr>
+          <p:cNvPr id="2" name="タイトル 1">
+            <a:extLst>
+              <a:ext uri="{FF2B5EF4-FFF2-40B4-BE49-F238E27FC236}">
+                <a16:creationId xmlns:a16="http://schemas.microsoft.com/office/drawing/2014/main" id="{8A585487-7D03-AFB4-785A-B5A349E481F2}"/>
+              </a:ext>
+            </a:extLst>
+          </p:cNvPr>
+          <p:cNvSpPr>
+            <a:spLocks noGrp="1"/>
+          </p:cNvSpPr>
+          <p:nvPr>
+            <p:ph type="title"/>
+          </p:nvPr>
+        </p:nvSpPr>
+        <p:spPr/>
+        <p:txBody>
+          <a:bodyPr/>
+          <a:lstStyle/>
+          <a:p>
+            <a:endParaRPr kumimoji="1" lang="ja-JP" altLang="en-US"/>
+          </a:p>
+        </p:txBody>
+      </p:sp>
+      <p:pic>
+        <p:nvPicPr>
+          <p:cNvPr id="5" name="図 4">
+            <a:extLst>
+              <a:ext uri="{FF2B5EF4-FFF2-40B4-BE49-F238E27FC236}">
+                <a16:creationId xmlns:a16="http://schemas.microsoft.com/office/drawing/2014/main" id="{AFBC609B-FE42-BEFD-3C2A-F6BA2286BC98}"/>
+              </a:ext>
+            </a:extLst>
+          </p:cNvPr>
+          <p:cNvPicPr>
+            <a:picLocks noChangeAspect="1"/>
+          </p:cNvPicPr>
+          <p:nvPr/>
+        </p:nvPicPr>
+        <p:blipFill>
+          <a:blip r:embed="rId2"/>
+          <a:srcRect l="16326" r="55447" b="66303"/>
+          <a:stretch>
+            <a:fillRect/>
+          </a:stretch>
+        </p:blipFill>
+        <p:spPr>
+          <a:xfrm>
+            <a:off x="2327563" y="57062"/>
+            <a:ext cx="3158837" cy="2272481"/>
+          </a:xfrm>
+          <a:prstGeom prst="rect">
+            <a:avLst/>
+          </a:prstGeom>
+        </p:spPr>
+      </p:pic>
+      <p:pic>
+        <p:nvPicPr>
+          <p:cNvPr id="6" name="図 5">
+            <a:extLst>
+              <a:ext uri="{FF2B5EF4-FFF2-40B4-BE49-F238E27FC236}">
+                <a16:creationId xmlns:a16="http://schemas.microsoft.com/office/drawing/2014/main" id="{23B6F6D5-FBC1-AC88-EE2F-868340AE2DA4}"/>
+              </a:ext>
+            </a:extLst>
+          </p:cNvPr>
+          <p:cNvPicPr>
+            <a:picLocks noChangeAspect="1"/>
+          </p:cNvPicPr>
+          <p:nvPr/>
+        </p:nvPicPr>
+        <p:blipFill>
+          <a:blip r:embed="rId2"/>
+          <a:srcRect l="44423" t="20568" r="1086"/>
+          <a:stretch>
+            <a:fillRect/>
+          </a:stretch>
+        </p:blipFill>
+        <p:spPr>
+          <a:xfrm>
+            <a:off x="2464055" y="2123053"/>
+            <a:ext cx="7087269" cy="5356767"/>
+          </a:xfrm>
+          <a:prstGeom prst="rect">
+            <a:avLst/>
+          </a:prstGeom>
+        </p:spPr>
+      </p:pic>
+      <p:pic>
+        <p:nvPicPr>
+          <p:cNvPr id="7" name="図 6">
+            <a:extLst>
+              <a:ext uri="{FF2B5EF4-FFF2-40B4-BE49-F238E27FC236}">
+                <a16:creationId xmlns:a16="http://schemas.microsoft.com/office/drawing/2014/main" id="{E46BBC1A-91E0-49C9-CBE7-9197D231E622}"/>
+              </a:ext>
+            </a:extLst>
+          </p:cNvPr>
+          <p:cNvPicPr>
+            <a:picLocks noChangeAspect="1"/>
+          </p:cNvPicPr>
+          <p:nvPr/>
+        </p:nvPicPr>
+        <p:blipFill>
+          <a:blip r:embed="rId2"/>
+          <a:srcRect t="28922" r="89659"/>
+          <a:stretch>
+            <a:fillRect/>
+          </a:stretch>
+        </p:blipFill>
+        <p:spPr>
+          <a:xfrm>
+            <a:off x="1385234" y="2329543"/>
+            <a:ext cx="1157199" cy="5150277"/>
+          </a:xfrm>
+          <a:prstGeom prst="rect">
+            <a:avLst/>
+          </a:prstGeom>
+        </p:spPr>
+      </p:pic>
+      <p:pic>
+        <p:nvPicPr>
+          <p:cNvPr id="8" name="図 7">
+            <a:extLst>
+              <a:ext uri="{FF2B5EF4-FFF2-40B4-BE49-F238E27FC236}">
+                <a16:creationId xmlns:a16="http://schemas.microsoft.com/office/drawing/2014/main" id="{579BE852-267A-1D90-AA17-FDF073E67F3C}"/>
+              </a:ext>
+            </a:extLst>
+          </p:cNvPr>
+          <p:cNvPicPr>
+            <a:picLocks noChangeAspect="1"/>
+          </p:cNvPicPr>
+          <p:nvPr/>
+        </p:nvPicPr>
+        <p:blipFill>
+          <a:blip r:embed="rId2"/>
+          <a:srcRect l="43969" b="79230"/>
+          <a:stretch>
+            <a:fillRect/>
+          </a:stretch>
+        </p:blipFill>
+        <p:spPr>
+          <a:xfrm>
+            <a:off x="5486401" y="57062"/>
+            <a:ext cx="6270317" cy="1400716"/>
+          </a:xfrm>
+          <a:prstGeom prst="rect">
+            <a:avLst/>
+          </a:prstGeom>
+        </p:spPr>
+      </p:pic>
+      <p:pic>
+        <p:nvPicPr>
+          <p:cNvPr id="9" name="図 8">
+            <a:extLst>
+              <a:ext uri="{FF2B5EF4-FFF2-40B4-BE49-F238E27FC236}">
+                <a16:creationId xmlns:a16="http://schemas.microsoft.com/office/drawing/2014/main" id="{DB5DBE39-B808-72C8-FD1F-EDC58EA4A7EC}"/>
+              </a:ext>
+            </a:extLst>
+          </p:cNvPr>
+          <p:cNvPicPr>
+            <a:picLocks noChangeAspect="1"/>
+          </p:cNvPicPr>
+          <p:nvPr/>
+        </p:nvPicPr>
+        <p:blipFill>
+          <a:blip r:embed="rId2"/>
+          <a:srcRect l="17122" t="31315" r="68352" b="58603"/>
+          <a:stretch>
+            <a:fillRect/>
+          </a:stretch>
+        </p:blipFill>
+        <p:spPr>
+          <a:xfrm>
+            <a:off x="5486401" y="1443148"/>
+            <a:ext cx="1625600" cy="679905"/>
+          </a:xfrm>
+          <a:prstGeom prst="rect">
+            <a:avLst/>
+          </a:prstGeom>
+        </p:spPr>
+      </p:pic>
+      <p:pic>
+        <p:nvPicPr>
+          <p:cNvPr id="10" name="図 9">
+            <a:extLst>
+              <a:ext uri="{FF2B5EF4-FFF2-40B4-BE49-F238E27FC236}">
+                <a16:creationId xmlns:a16="http://schemas.microsoft.com/office/drawing/2014/main" id="{D452709E-D846-7576-DDCE-620526922442}"/>
+              </a:ext>
+            </a:extLst>
+          </p:cNvPr>
+          <p:cNvPicPr>
+            <a:picLocks noChangeAspect="1"/>
+          </p:cNvPicPr>
+          <p:nvPr/>
+        </p:nvPicPr>
+        <p:blipFill>
+          <a:blip r:embed="rId2"/>
+          <a:srcRect r="90360" b="66303"/>
+          <a:stretch>
+            <a:fillRect/>
+          </a:stretch>
+        </p:blipFill>
+        <p:spPr>
+          <a:xfrm>
+            <a:off x="1385234" y="57062"/>
+            <a:ext cx="1078821" cy="2272481"/>
+          </a:xfrm>
+          <a:prstGeom prst="rect">
+            <a:avLst/>
+          </a:prstGeom>
+        </p:spPr>
+      </p:pic>
+      <p:pic>
+        <p:nvPicPr>
+          <p:cNvPr id="11" name="図 10">
+            <a:extLst>
+              <a:ext uri="{FF2B5EF4-FFF2-40B4-BE49-F238E27FC236}">
+                <a16:creationId xmlns:a16="http://schemas.microsoft.com/office/drawing/2014/main" id="{D41A9F51-3C14-89C9-9706-781117494610}"/>
+              </a:ext>
+            </a:extLst>
+          </p:cNvPr>
+          <p:cNvPicPr>
+            <a:picLocks noChangeAspect="1"/>
+          </p:cNvPicPr>
+          <p:nvPr/>
+        </p:nvPicPr>
+        <p:blipFill>
+          <a:blip r:embed="rId2"/>
+          <a:srcRect l="43969" b="79230"/>
+          <a:stretch>
+            <a:fillRect/>
+          </a:stretch>
+        </p:blipFill>
+        <p:spPr>
+          <a:xfrm>
+            <a:off x="5486401" y="-1497685"/>
+            <a:ext cx="6270317" cy="1400716"/>
+          </a:xfrm>
+          <a:prstGeom prst="rect">
+            <a:avLst/>
+          </a:prstGeom>
+        </p:spPr>
+      </p:pic>
+    </p:spTree>
+    <p:extLst>
+      <p:ext uri="{BB962C8B-B14F-4D97-AF65-F5344CB8AC3E}">
+        <p14:creationId xmlns:p14="http://schemas.microsoft.com/office/powerpoint/2010/main" val="4106731250"/>
+      </p:ext>
+    </p:extLst>
+  </p:cSld>
+  <p:clrMapOvr>
+    <a:masterClrMapping/>
+  </p:clrMapOvr>
+</p:sld>
+</file>
+
 <file path=ppt/slides/slide2.xml><?xml version="1.0" encoding="utf-8"?>
 <p:sld xmlns:a="http://schemas.openxmlformats.org/drawingml/2006/main" xmlns:r="http://schemas.openxmlformats.org/officeDocument/2006/relationships" xmlns:p="http://schemas.openxmlformats.org/presentationml/2006/main">
   <p:cSld>
@@ -5592,6 +6154,644 @@
     <p:extLst>
       <p:ext uri="{BB962C8B-B14F-4D97-AF65-F5344CB8AC3E}">
         <p14:creationId xmlns:p14="http://schemas.microsoft.com/office/powerpoint/2010/main" val="1929965221"/>
+      </p:ext>
+    </p:extLst>
+  </p:cSld>
+  <p:clrMapOvr>
+    <a:masterClrMapping/>
+  </p:clrMapOvr>
+</p:sld>
+</file>
+
+<file path=ppt/slides/slide5.xml><?xml version="1.0" encoding="utf-8"?>
+<p:sld xmlns:a="http://schemas.openxmlformats.org/drawingml/2006/main" xmlns:r="http://schemas.openxmlformats.org/officeDocument/2006/relationships" xmlns:p="http://schemas.openxmlformats.org/presentationml/2006/main">
+  <p:cSld>
+    <p:spTree>
+      <p:nvGrpSpPr>
+        <p:cNvPr id="1" name=""/>
+        <p:cNvGrpSpPr/>
+        <p:nvPr/>
+      </p:nvGrpSpPr>
+      <p:grpSpPr>
+        <a:xfrm>
+          <a:off x="0" y="0"/>
+          <a:ext cx="0" cy="0"/>
+          <a:chOff x="0" y="0"/>
+          <a:chExt cx="0" cy="0"/>
+        </a:xfrm>
+      </p:grpSpPr>
+      <p:pic>
+        <p:nvPicPr>
+          <p:cNvPr id="10" name="図 9">
+            <a:extLst>
+              <a:ext uri="{FF2B5EF4-FFF2-40B4-BE49-F238E27FC236}">
+                <a16:creationId xmlns:a16="http://schemas.microsoft.com/office/drawing/2014/main" id="{F82B43CD-2981-A736-68EC-75BDE10FD02D}"/>
+              </a:ext>
+            </a:extLst>
+          </p:cNvPr>
+          <p:cNvPicPr>
+            <a:picLocks noChangeAspect="1"/>
+          </p:cNvPicPr>
+          <p:nvPr/>
+        </p:nvPicPr>
+        <p:blipFill>
+          <a:blip r:embed="rId2"/>
+          <a:stretch>
+            <a:fillRect/>
+          </a:stretch>
+        </p:blipFill>
+        <p:spPr>
+          <a:xfrm>
+            <a:off x="554182" y="2899652"/>
+            <a:ext cx="11083636" cy="1058696"/>
+          </a:xfrm>
+          <a:prstGeom prst="rect">
+            <a:avLst/>
+          </a:prstGeom>
+        </p:spPr>
+      </p:pic>
+    </p:spTree>
+    <p:extLst>
+      <p:ext uri="{BB962C8B-B14F-4D97-AF65-F5344CB8AC3E}">
+        <p14:creationId xmlns:p14="http://schemas.microsoft.com/office/powerpoint/2010/main" val="3926862690"/>
+      </p:ext>
+    </p:extLst>
+  </p:cSld>
+  <p:clrMapOvr>
+    <a:masterClrMapping/>
+  </p:clrMapOvr>
+</p:sld>
+</file>
+
+<file path=ppt/slides/slide6.xml><?xml version="1.0" encoding="utf-8"?>
+<p:sld xmlns:a="http://schemas.openxmlformats.org/drawingml/2006/main" xmlns:r="http://schemas.openxmlformats.org/officeDocument/2006/relationships" xmlns:p="http://schemas.openxmlformats.org/presentationml/2006/main">
+  <p:cSld>
+    <p:spTree>
+      <p:nvGrpSpPr>
+        <p:cNvPr id="1" name=""/>
+        <p:cNvGrpSpPr/>
+        <p:nvPr/>
+      </p:nvGrpSpPr>
+      <p:grpSpPr>
+        <a:xfrm>
+          <a:off x="0" y="0"/>
+          <a:ext cx="0" cy="0"/>
+          <a:chOff x="0" y="0"/>
+          <a:chExt cx="0" cy="0"/>
+        </a:xfrm>
+      </p:grpSpPr>
+      <p:pic>
+        <p:nvPicPr>
+          <p:cNvPr id="5" name="図 4">
+            <a:extLst>
+              <a:ext uri="{FF2B5EF4-FFF2-40B4-BE49-F238E27FC236}">
+                <a16:creationId xmlns:a16="http://schemas.microsoft.com/office/drawing/2014/main" id="{DBD1AD76-608C-9F4F-6858-38EEB4E01C65}"/>
+              </a:ext>
+            </a:extLst>
+          </p:cNvPr>
+          <p:cNvPicPr>
+            <a:picLocks noChangeAspect="1"/>
+          </p:cNvPicPr>
+          <p:nvPr/>
+        </p:nvPicPr>
+        <p:blipFill>
+          <a:blip r:embed="rId2"/>
+          <a:stretch>
+            <a:fillRect/>
+          </a:stretch>
+        </p:blipFill>
+        <p:spPr>
+          <a:xfrm>
+            <a:off x="132177" y="0"/>
+            <a:ext cx="11927645" cy="6858000"/>
+          </a:xfrm>
+          <a:prstGeom prst="rect">
+            <a:avLst/>
+          </a:prstGeom>
+        </p:spPr>
+      </p:pic>
+    </p:spTree>
+    <p:extLst>
+      <p:ext uri="{BB962C8B-B14F-4D97-AF65-F5344CB8AC3E}">
+        <p14:creationId xmlns:p14="http://schemas.microsoft.com/office/powerpoint/2010/main" val="3649926513"/>
+      </p:ext>
+    </p:extLst>
+  </p:cSld>
+  <p:clrMapOvr>
+    <a:masterClrMapping/>
+  </p:clrMapOvr>
+</p:sld>
+</file>
+
+<file path=ppt/slides/slide7.xml><?xml version="1.0" encoding="utf-8"?>
+<p:sld xmlns:a="http://schemas.openxmlformats.org/drawingml/2006/main" xmlns:r="http://schemas.openxmlformats.org/officeDocument/2006/relationships" xmlns:p="http://schemas.openxmlformats.org/presentationml/2006/main">
+  <p:cSld>
+    <p:spTree>
+      <p:nvGrpSpPr>
+        <p:cNvPr id="1" name="">
+          <a:extLst>
+            <a:ext uri="{FF2B5EF4-FFF2-40B4-BE49-F238E27FC236}">
+              <a16:creationId xmlns:a16="http://schemas.microsoft.com/office/drawing/2014/main" id="{C6484545-8274-96C4-05EB-DDA1F6179D55}"/>
+            </a:ext>
+          </a:extLst>
+        </p:cNvPr>
+        <p:cNvGrpSpPr/>
+        <p:nvPr/>
+      </p:nvGrpSpPr>
+      <p:grpSpPr>
+        <a:xfrm>
+          <a:off x="0" y="0"/>
+          <a:ext cx="0" cy="0"/>
+          <a:chOff x="0" y="0"/>
+          <a:chExt cx="0" cy="0"/>
+        </a:xfrm>
+      </p:grpSpPr>
+      <p:pic>
+        <p:nvPicPr>
+          <p:cNvPr id="5" name="図 4">
+            <a:extLst>
+              <a:ext uri="{FF2B5EF4-FFF2-40B4-BE49-F238E27FC236}">
+                <a16:creationId xmlns:a16="http://schemas.microsoft.com/office/drawing/2014/main" id="{25D2D48E-5684-4D92-52EA-8006623210B2}"/>
+              </a:ext>
+            </a:extLst>
+          </p:cNvPr>
+          <p:cNvPicPr>
+            <a:picLocks noChangeAspect="1"/>
+          </p:cNvPicPr>
+          <p:nvPr/>
+        </p:nvPicPr>
+        <p:blipFill>
+          <a:blip r:embed="rId2"/>
+          <a:stretch>
+            <a:fillRect/>
+          </a:stretch>
+        </p:blipFill>
+        <p:spPr>
+          <a:xfrm>
+            <a:off x="132177" y="0"/>
+            <a:ext cx="11927645" cy="6858000"/>
+          </a:xfrm>
+          <a:prstGeom prst="rect">
+            <a:avLst/>
+          </a:prstGeom>
+        </p:spPr>
+      </p:pic>
+      <p:pic>
+        <p:nvPicPr>
+          <p:cNvPr id="6" name="図 5">
+            <a:extLst>
+              <a:ext uri="{FF2B5EF4-FFF2-40B4-BE49-F238E27FC236}">
+                <a16:creationId xmlns:a16="http://schemas.microsoft.com/office/drawing/2014/main" id="{0B865E27-1BBB-46A7-D8F8-7DDBB4B72F06}"/>
+              </a:ext>
+            </a:extLst>
+          </p:cNvPr>
+          <p:cNvPicPr>
+            <a:picLocks noChangeAspect="1"/>
+          </p:cNvPicPr>
+          <p:nvPr/>
+        </p:nvPicPr>
+        <p:blipFill>
+          <a:blip r:embed="rId3"/>
+          <a:stretch>
+            <a:fillRect/>
+          </a:stretch>
+        </p:blipFill>
+        <p:spPr>
+          <a:xfrm>
+            <a:off x="2343829" y="4037407"/>
+            <a:ext cx="2150946" cy="510850"/>
+          </a:xfrm>
+          <a:prstGeom prst="rect">
+            <a:avLst/>
+          </a:prstGeom>
+        </p:spPr>
+      </p:pic>
+      <p:sp>
+        <p:nvSpPr>
+          <p:cNvPr id="7" name="正方形/長方形 6">
+            <a:extLst>
+              <a:ext uri="{FF2B5EF4-FFF2-40B4-BE49-F238E27FC236}">
+                <a16:creationId xmlns:a16="http://schemas.microsoft.com/office/drawing/2014/main" id="{8048CCAD-4F30-174B-9E28-A919FA9D4DB6}"/>
+              </a:ext>
+            </a:extLst>
+          </p:cNvPr>
+          <p:cNvSpPr/>
+          <p:nvPr/>
+        </p:nvSpPr>
+        <p:spPr>
+          <a:xfrm>
+            <a:off x="2641600" y="4227286"/>
+            <a:ext cx="593271" cy="154214"/>
+          </a:xfrm>
+          <a:prstGeom prst="rect">
+            <a:avLst/>
+          </a:prstGeom>
+          <a:solidFill>
+            <a:srgbClr val="181C2A"/>
+          </a:solidFill>
+          <a:ln>
+            <a:noFill/>
+          </a:ln>
+        </p:spPr>
+        <p:style>
+          <a:lnRef idx="2">
+            <a:schemeClr val="accent1">
+              <a:shade val="15000"/>
+            </a:schemeClr>
+          </a:lnRef>
+          <a:fillRef idx="1">
+            <a:schemeClr val="accent1"/>
+          </a:fillRef>
+          <a:effectRef idx="0">
+            <a:schemeClr val="accent1"/>
+          </a:effectRef>
+          <a:fontRef idx="minor">
+            <a:schemeClr val="lt1"/>
+          </a:fontRef>
+        </p:style>
+        <p:txBody>
+          <a:bodyPr rtlCol="0" anchor="ctr"/>
+          <a:lstStyle/>
+          <a:p>
+            <a:pPr algn="ctr"/>
+            <a:endParaRPr kumimoji="1" lang="ja-JP" altLang="en-US"/>
+          </a:p>
+        </p:txBody>
+      </p:sp>
+      <p:sp>
+        <p:nvSpPr>
+          <p:cNvPr id="8" name="テキスト ボックス 7">
+            <a:extLst>
+              <a:ext uri="{FF2B5EF4-FFF2-40B4-BE49-F238E27FC236}">
+                <a16:creationId xmlns:a16="http://schemas.microsoft.com/office/drawing/2014/main" id="{E12CEEA9-210A-CBFB-7F7D-0A4A1A475C28}"/>
+              </a:ext>
+            </a:extLst>
+          </p:cNvPr>
+          <p:cNvSpPr txBox="1"/>
+          <p:nvPr/>
+        </p:nvSpPr>
+        <p:spPr>
+          <a:xfrm>
+            <a:off x="2530928" y="4197173"/>
+            <a:ext cx="830944" cy="215444"/>
+          </a:xfrm>
+          <a:prstGeom prst="rect">
+            <a:avLst/>
+          </a:prstGeom>
+          <a:noFill/>
+        </p:spPr>
+        <p:txBody>
+          <a:bodyPr wrap="square" rtlCol="0">
+            <a:spAutoFit/>
+          </a:bodyPr>
+          <a:lstStyle/>
+          <a:p>
+            <a:pPr algn="ctr"/>
+            <a:r>
+              <a:rPr kumimoji="1" lang="en-US" altLang="ja-JP" sz="800" b="1" dirty="0">
+                <a:solidFill>
+                  <a:schemeClr val="bg1"/>
+                </a:solidFill>
+                <a:latin typeface="JetBrains Mono" panose="02000009000000000000" pitchFamily="49" charset="0"/>
+                <a:cs typeface="JetBrains Mono" panose="02000009000000000000" pitchFamily="49" charset="0"/>
+              </a:rPr>
+              <a:t>DIGEST</a:t>
+            </a:r>
+            <a:endParaRPr kumimoji="1" lang="ja-JP" altLang="en-US" sz="800" b="1" dirty="0">
+              <a:solidFill>
+                <a:schemeClr val="bg1"/>
+              </a:solidFill>
+              <a:latin typeface="JetBrains Mono" panose="02000009000000000000" pitchFamily="49" charset="0"/>
+              <a:cs typeface="JetBrains Mono" panose="02000009000000000000" pitchFamily="49" charset="0"/>
+            </a:endParaRPr>
+          </a:p>
+        </p:txBody>
+      </p:sp>
+    </p:spTree>
+    <p:extLst>
+      <p:ext uri="{BB962C8B-B14F-4D97-AF65-F5344CB8AC3E}">
+        <p14:creationId xmlns:p14="http://schemas.microsoft.com/office/powerpoint/2010/main" val="1011609580"/>
+      </p:ext>
+    </p:extLst>
+  </p:cSld>
+  <p:clrMapOvr>
+    <a:masterClrMapping/>
+  </p:clrMapOvr>
+</p:sld>
+</file>
+
+<file path=ppt/slides/slide8.xml><?xml version="1.0" encoding="utf-8"?>
+<p:sld xmlns:a="http://schemas.openxmlformats.org/drawingml/2006/main" xmlns:r="http://schemas.openxmlformats.org/officeDocument/2006/relationships" xmlns:p="http://schemas.openxmlformats.org/presentationml/2006/main">
+  <p:cSld>
+    <p:spTree>
+      <p:nvGrpSpPr>
+        <p:cNvPr id="1" name="">
+          <a:extLst>
+            <a:ext uri="{FF2B5EF4-FFF2-40B4-BE49-F238E27FC236}">
+              <a16:creationId xmlns:a16="http://schemas.microsoft.com/office/drawing/2014/main" id="{33290B90-E60F-C6AC-6597-F261248B8A24}"/>
+            </a:ext>
+          </a:extLst>
+        </p:cNvPr>
+        <p:cNvGrpSpPr/>
+        <p:nvPr/>
+      </p:nvGrpSpPr>
+      <p:grpSpPr>
+        <a:xfrm>
+          <a:off x="0" y="0"/>
+          <a:ext cx="0" cy="0"/>
+          <a:chOff x="0" y="0"/>
+          <a:chExt cx="0" cy="0"/>
+        </a:xfrm>
+      </p:grpSpPr>
+      <p:pic>
+        <p:nvPicPr>
+          <p:cNvPr id="5" name="図 4">
+            <a:extLst>
+              <a:ext uri="{FF2B5EF4-FFF2-40B4-BE49-F238E27FC236}">
+                <a16:creationId xmlns:a16="http://schemas.microsoft.com/office/drawing/2014/main" id="{CC46E2DD-0192-1C65-86AB-31A6992DC13A}"/>
+              </a:ext>
+            </a:extLst>
+          </p:cNvPr>
+          <p:cNvPicPr>
+            <a:picLocks noChangeAspect="1"/>
+          </p:cNvPicPr>
+          <p:nvPr/>
+        </p:nvPicPr>
+        <p:blipFill>
+          <a:blip r:embed="rId2"/>
+          <a:stretch>
+            <a:fillRect/>
+          </a:stretch>
+        </p:blipFill>
+        <p:spPr>
+          <a:xfrm>
+            <a:off x="132177" y="0"/>
+            <a:ext cx="11927645" cy="6858000"/>
+          </a:xfrm>
+          <a:prstGeom prst="rect">
+            <a:avLst/>
+          </a:prstGeom>
+        </p:spPr>
+      </p:pic>
+      <p:pic>
+        <p:nvPicPr>
+          <p:cNvPr id="6" name="図 5">
+            <a:extLst>
+              <a:ext uri="{FF2B5EF4-FFF2-40B4-BE49-F238E27FC236}">
+                <a16:creationId xmlns:a16="http://schemas.microsoft.com/office/drawing/2014/main" id="{FE715BE0-D6F2-C2BA-E20A-1AF2F8B19AC5}"/>
+              </a:ext>
+            </a:extLst>
+          </p:cNvPr>
+          <p:cNvPicPr>
+            <a:picLocks noChangeAspect="1"/>
+          </p:cNvPicPr>
+          <p:nvPr/>
+        </p:nvPicPr>
+        <p:blipFill>
+          <a:blip r:embed="rId3"/>
+          <a:stretch>
+            <a:fillRect/>
+          </a:stretch>
+        </p:blipFill>
+        <p:spPr>
+          <a:xfrm>
+            <a:off x="2343829" y="4037407"/>
+            <a:ext cx="2150946" cy="510850"/>
+          </a:xfrm>
+          <a:prstGeom prst="rect">
+            <a:avLst/>
+          </a:prstGeom>
+        </p:spPr>
+      </p:pic>
+      <p:pic>
+        <p:nvPicPr>
+          <p:cNvPr id="3" name="図 2">
+            <a:extLst>
+              <a:ext uri="{FF2B5EF4-FFF2-40B4-BE49-F238E27FC236}">
+                <a16:creationId xmlns:a16="http://schemas.microsoft.com/office/drawing/2014/main" id="{22AE00FD-B569-7785-DE34-4FA982F21410}"/>
+              </a:ext>
+            </a:extLst>
+          </p:cNvPr>
+          <p:cNvPicPr>
+            <a:picLocks noChangeAspect="1"/>
+          </p:cNvPicPr>
+          <p:nvPr/>
+        </p:nvPicPr>
+        <p:blipFill>
+          <a:blip r:embed="rId4"/>
+          <a:stretch>
+            <a:fillRect/>
+          </a:stretch>
+        </p:blipFill>
+        <p:spPr>
+          <a:xfrm>
+            <a:off x="2386848" y="4053539"/>
+            <a:ext cx="2064908" cy="478585"/>
+          </a:xfrm>
+          <a:prstGeom prst="rect">
+            <a:avLst/>
+          </a:prstGeom>
+        </p:spPr>
+      </p:pic>
+      <p:sp>
+        <p:nvSpPr>
+          <p:cNvPr id="7" name="正方形/長方形 6">
+            <a:extLst>
+              <a:ext uri="{FF2B5EF4-FFF2-40B4-BE49-F238E27FC236}">
+                <a16:creationId xmlns:a16="http://schemas.microsoft.com/office/drawing/2014/main" id="{450B30CD-2EC8-E800-2911-2AEDD19E3B80}"/>
+              </a:ext>
+            </a:extLst>
+          </p:cNvPr>
+          <p:cNvSpPr/>
+          <p:nvPr/>
+        </p:nvSpPr>
+        <p:spPr>
+          <a:xfrm>
+            <a:off x="2641600" y="4227286"/>
+            <a:ext cx="593271" cy="154214"/>
+          </a:xfrm>
+          <a:prstGeom prst="rect">
+            <a:avLst/>
+          </a:prstGeom>
+          <a:solidFill>
+            <a:schemeClr val="bg1"/>
+          </a:solidFill>
+          <a:ln>
+            <a:noFill/>
+          </a:ln>
+        </p:spPr>
+        <p:style>
+          <a:lnRef idx="2">
+            <a:schemeClr val="accent1">
+              <a:shade val="15000"/>
+            </a:schemeClr>
+          </a:lnRef>
+          <a:fillRef idx="1">
+            <a:schemeClr val="accent1"/>
+          </a:fillRef>
+          <a:effectRef idx="0">
+            <a:schemeClr val="accent1"/>
+          </a:effectRef>
+          <a:fontRef idx="minor">
+            <a:schemeClr val="lt1"/>
+          </a:fontRef>
+        </p:style>
+        <p:txBody>
+          <a:bodyPr rtlCol="0" anchor="ctr"/>
+          <a:lstStyle/>
+          <a:p>
+            <a:pPr algn="ctr"/>
+            <a:endParaRPr kumimoji="1" lang="ja-JP" altLang="en-US"/>
+          </a:p>
+        </p:txBody>
+      </p:sp>
+      <p:sp>
+        <p:nvSpPr>
+          <p:cNvPr id="8" name="テキスト ボックス 7">
+            <a:extLst>
+              <a:ext uri="{FF2B5EF4-FFF2-40B4-BE49-F238E27FC236}">
+                <a16:creationId xmlns:a16="http://schemas.microsoft.com/office/drawing/2014/main" id="{83A3D000-BE08-27AF-8023-B4EA28FE90A8}"/>
+              </a:ext>
+            </a:extLst>
+          </p:cNvPr>
+          <p:cNvSpPr txBox="1"/>
+          <p:nvPr/>
+        </p:nvSpPr>
+        <p:spPr>
+          <a:xfrm>
+            <a:off x="2544537" y="4217025"/>
+            <a:ext cx="830944" cy="215444"/>
+          </a:xfrm>
+          <a:prstGeom prst="rect">
+            <a:avLst/>
+          </a:prstGeom>
+          <a:noFill/>
+        </p:spPr>
+        <p:txBody>
+          <a:bodyPr wrap="square" rtlCol="0">
+            <a:spAutoFit/>
+          </a:bodyPr>
+          <a:lstStyle/>
+          <a:p>
+            <a:pPr algn="ctr"/>
+            <a:r>
+              <a:rPr kumimoji="1" lang="en-US" altLang="ja-JP" sz="800" b="1" dirty="0">
+                <a:solidFill>
+                  <a:schemeClr val="bg1">
+                    <a:lumMod val="50000"/>
+                  </a:schemeClr>
+                </a:solidFill>
+                <a:latin typeface="JetBrains Mono" panose="02000009000000000000" pitchFamily="49" charset="0"/>
+                <a:cs typeface="JetBrains Mono" panose="02000009000000000000" pitchFamily="49" charset="0"/>
+              </a:rPr>
+              <a:t>DIGEST</a:t>
+            </a:r>
+            <a:endParaRPr kumimoji="1" lang="ja-JP" altLang="en-US" sz="800" b="1" dirty="0">
+              <a:solidFill>
+                <a:schemeClr val="bg1">
+                  <a:lumMod val="50000"/>
+                </a:schemeClr>
+              </a:solidFill>
+              <a:latin typeface="JetBrains Mono" panose="02000009000000000000" pitchFamily="49" charset="0"/>
+              <a:cs typeface="JetBrains Mono" panose="02000009000000000000" pitchFamily="49" charset="0"/>
+            </a:endParaRPr>
+          </a:p>
+        </p:txBody>
+      </p:sp>
+    </p:spTree>
+    <p:extLst>
+      <p:ext uri="{BB962C8B-B14F-4D97-AF65-F5344CB8AC3E}">
+        <p14:creationId xmlns:p14="http://schemas.microsoft.com/office/powerpoint/2010/main" val="1313257984"/>
+      </p:ext>
+    </p:extLst>
+  </p:cSld>
+  <p:clrMapOvr>
+    <a:masterClrMapping/>
+  </p:clrMapOvr>
+</p:sld>
+</file>
+
+<file path=ppt/slides/slide9.xml><?xml version="1.0" encoding="utf-8"?>
+<p:sld xmlns:a="http://schemas.openxmlformats.org/drawingml/2006/main" xmlns:r="http://schemas.openxmlformats.org/officeDocument/2006/relationships" xmlns:p="http://schemas.openxmlformats.org/presentationml/2006/main">
+  <p:cSld>
+    <p:spTree>
+      <p:nvGrpSpPr>
+        <p:cNvPr id="1" name=""/>
+        <p:cNvGrpSpPr/>
+        <p:nvPr/>
+      </p:nvGrpSpPr>
+      <p:grpSpPr>
+        <a:xfrm>
+          <a:off x="0" y="0"/>
+          <a:ext cx="0" cy="0"/>
+          <a:chOff x="0" y="0"/>
+          <a:chExt cx="0" cy="0"/>
+        </a:xfrm>
+      </p:grpSpPr>
+      <p:pic>
+        <p:nvPicPr>
+          <p:cNvPr id="5" name="図 4">
+            <a:extLst>
+              <a:ext uri="{FF2B5EF4-FFF2-40B4-BE49-F238E27FC236}">
+                <a16:creationId xmlns:a16="http://schemas.microsoft.com/office/drawing/2014/main" id="{A1E39F8B-33A3-0653-E6CF-700635386D92}"/>
+              </a:ext>
+            </a:extLst>
+          </p:cNvPr>
+          <p:cNvPicPr>
+            <a:picLocks noChangeAspect="1"/>
+          </p:cNvPicPr>
+          <p:nvPr/>
+        </p:nvPicPr>
+        <p:blipFill>
+          <a:blip r:embed="rId2"/>
+          <a:stretch>
+            <a:fillRect/>
+          </a:stretch>
+        </p:blipFill>
+        <p:spPr>
+          <a:xfrm>
+            <a:off x="0" y="471401"/>
+            <a:ext cx="12192000" cy="5915198"/>
+          </a:xfrm>
+          <a:prstGeom prst="rect">
+            <a:avLst/>
+          </a:prstGeom>
+        </p:spPr>
+      </p:pic>
+      <p:pic>
+        <p:nvPicPr>
+          <p:cNvPr id="6" name="図 5">
+            <a:extLst>
+              <a:ext uri="{FF2B5EF4-FFF2-40B4-BE49-F238E27FC236}">
+                <a16:creationId xmlns:a16="http://schemas.microsoft.com/office/drawing/2014/main" id="{0072B4DB-E89C-F952-07D1-72DE1B97FEDB}"/>
+              </a:ext>
+            </a:extLst>
+          </p:cNvPr>
+          <p:cNvPicPr>
+            <a:picLocks noChangeAspect="1"/>
+          </p:cNvPicPr>
+          <p:nvPr/>
+        </p:nvPicPr>
+        <p:blipFill>
+          <a:blip r:embed="rId2"/>
+          <a:stretch>
+            <a:fillRect/>
+          </a:stretch>
+        </p:blipFill>
+        <p:spPr>
+          <a:xfrm>
+            <a:off x="0" y="615864"/>
+            <a:ext cx="12192000" cy="5915198"/>
+          </a:xfrm>
+          <a:prstGeom prst="rect">
+            <a:avLst/>
+          </a:prstGeom>
+        </p:spPr>
+      </p:pic>
+    </p:spTree>
+    <p:extLst>
+      <p:ext uri="{BB962C8B-B14F-4D97-AF65-F5344CB8AC3E}">
+        <p14:creationId xmlns:p14="http://schemas.microsoft.com/office/powerpoint/2010/main" val="1537342895"/>
       </p:ext>
     </p:extLst>
   </p:cSld>

</xml_diff>